<commit_message>
fix: Correct poster template typos and nb17 rubric pointers
The poster template attached to M09 and M10 had six typos in its
placeholder text (CRIPS-DM, "Mitch. Daniels", "what did you find you
find out", "why is the problem is", "overview of you what", "what
you're talk about"). nb17 told students the grading rubric lives inside
Milestone 04, the Summer numbering; it now points to the rubric attached
to Milestones 09 and 10. Instructor copy edited first.

Co-Authored-By: Claude Opus 5.5 <noreply@anthropic.com>
</commit_message>
<xml_diff>
--- a/_final_project/2026F/template/qm474_poster_template.pptx
+++ b/_final_project/2026F/template/qm474_poster_template.pptx
@@ -10370,7 +10370,7 @@
                 <a:latin typeface="Arial" panose="020B0604020202020204" pitchFamily="34" charset="0"/>
                 <a:cs typeface="Arial" panose="020B0604020202020204" pitchFamily="34" charset="0"/>
               </a:rPr>
-              <a:t>What did you do? Why did you do this project (who cares?)? What did you find you find out? No more than 200 words here.</a:t>
+              <a:t>What did you do? Why did you do this project (who cares?)? What did you find out? No more than 200 words here.</a:t>
             </a:r>
           </a:p>
           <a:p>
@@ -11314,7 +11314,7 @@
                 <a:latin typeface="Arial" panose="020B0604020202020204" pitchFamily="34" charset="0"/>
                 <a:cs typeface="Arial" panose="020B0604020202020204" pitchFamily="34" charset="0"/>
               </a:rPr>
-              <a:t>as you would in the business understanding phase of CRIPS-DM.</a:t>
+              <a:t>as you would in the business understanding phase of CRISP-DM.</a:t>
             </a:r>
           </a:p>
           <a:p>
@@ -11331,7 +11331,7 @@
                 <a:latin typeface="Arial" panose="020B0604020202020204" pitchFamily="34" charset="0"/>
                 <a:cs typeface="Arial" panose="020B0604020202020204" pitchFamily="34" charset="0"/>
               </a:rPr>
-              <a:t>Motivate why is the problem is important …Cite at least two sources from mainstream media, white papers, or blogs that are no older than 2 years old that provide stats that help you motivate your problem.</a:t>
+              <a:t>Motivate why the problem is important …Cite at least two sources from mainstream media, white papers, or blogs that are no older than 2 years old that provide stats that help you motivate your problem.</a:t>
             </a:r>
           </a:p>
           <a:p>
@@ -11348,7 +11348,7 @@
                 <a:latin typeface="Arial" panose="020B0604020202020204" pitchFamily="34" charset="0"/>
                 <a:cs typeface="Arial" panose="020B0604020202020204" pitchFamily="34" charset="0"/>
               </a:rPr>
-              <a:t>Maybe add in a pretty illustration of what you’re talk about…Remember a poster is NOT a paper, but a high-level overview of you what you investigated. You are sort of using your poster like a PowerPoint deck and thus will want more</a:t>
+              <a:t>Maybe add in a pretty illustration of what you’re talking about…Remember a poster is NOT a paper, but a high-level overview of what you investigated. You are sort of using your poster like a PowerPoint deck and thus will want more</a:t>
             </a:r>
             <a:r>
               <a:rPr lang="en-US" sz="1594" dirty="0">
@@ -11861,7 +11861,7 @@
           <a:p>
             <a:r>
               <a:rPr lang="en-US" sz="1586" i="1" dirty="0"/>
-              <a:t>We want to thank Professor Davi Moreira for his mentorship throughout the project. We are also grateful to our TAs, First Name Last Name and First Name Last Name, for their guidance. This work was supported by the Mitch. Daniels School of Business. We also acknowledge the Undergraduate Research Center and Purdue University for providing this valuable opportunity.</a:t>
+              <a:t>We want to thank Professor Davi Moreira for his mentorship throughout the project. We are also grateful to our TAs, First Name Last Name and First Name Last Name, for their guidance. This work was supported by the Mitch Daniels School of Business. We also acknowledge the Undergraduate Research Center and Purdue University for providing this valuable opportunity.</a:t>
             </a:r>
             <a:endParaRPr lang="en-US" sz="1586" dirty="0"/>
           </a:p>

</xml_diff>

<commit_message>
feat: Revise the poster rubric and add an AI-use disclosure
Rubric: Data Preparation 20 -> 18, Baseline 20 -> 17, criterion 6
rewritten to the paired per-fold comparison against a predeclared
margin (CV inference doctrine; feedback only at M09, scored from M10),
and a new 5-point criterion 8 for sources, acknowledgments, AI use
disclosure and data privacy. Notes cover the honors section. Total 100.

Template: an AI USE DISCLOSURE section under Acknowledgements, per the
syllabus AI Policy. M09/M10 instructions and the milestone reference
updated to match.

Co-Authored-By: Claude Opus 5.5 <noreply@anthropic.com>
</commit_message>
<xml_diff>
--- a/_final_project/2026F/template/qm474_poster_template.pptx
+++ b/_final_project/2026F/template/qm474_poster_template.pptx
@@ -11753,7 +11753,7 @@
         </p:nvSpPr>
         <p:spPr bwMode="auto">
           <a:xfrm>
-            <a:off x="24298634" y="16747363"/>
+            <a:off x="24298634" y="15636240"/>
             <a:ext cx="6773131" cy="474338"/>
           </a:xfrm>
           <a:prstGeom prst="rect">
@@ -11803,7 +11803,7 @@
         </p:nvSpPr>
         <p:spPr>
           <a:xfrm>
-            <a:off x="26147668" y="16771742"/>
+            <a:off x="26147668" y="15660619"/>
             <a:ext cx="3249734" cy="389635"/>
           </a:xfrm>
           <a:prstGeom prst="rect">
@@ -11845,7 +11845,7 @@
         </p:nvSpPr>
         <p:spPr>
           <a:xfrm>
-            <a:off x="24484290" y="17416598"/>
+            <a:off x="24484290" y="16305475"/>
             <a:ext cx="6279886" cy="1555915"/>
           </a:xfrm>
           <a:prstGeom prst="rect">
@@ -11862,6 +11862,116 @@
             <a:r>
               <a:rPr lang="en-US" sz="1586" i="1" dirty="0"/>
               <a:t>We want to thank Professor Davi Moreira for his mentorship throughout the project. We are also grateful to our TAs, First Name Last Name and First Name Last Name, for their guidance. This work was supported by the Mitch Daniels School of Business. We also acknowledge the Undergraduate Research Center and Purdue University for providing this valuable opportunity.</a:t>
+            </a:r>
+            <a:endParaRPr lang="en-US" sz="1586" dirty="0"/>
+          </a:p>
+        </p:txBody>
+      </p:sp>
+      <p:sp>
+        <p:nvSpPr>
+          <p:cNvPr id="26648" name="AI Disclosure Bar"/>
+          <p:cNvSpPr/>
+          <p:nvPr/>
+        </p:nvSpPr>
+        <p:spPr bwMode="auto">
+          <a:xfrm>
+            <a:off x="24298634" y="17940528"/>
+            <a:ext cx="6773131" cy="474338"/>
+          </a:xfrm>
+          <a:prstGeom prst="rect">
+            <a:avLst/>
+          </a:prstGeom>
+          <a:solidFill>
+            <a:schemeClr val="tx1"/>
+          </a:solidFill>
+          <a:ln w="9525" cap="flat" cmpd="sng" algn="ctr">
+            <a:solidFill>
+              <a:schemeClr val="tx1">
+                <a:lumMod val="50000"/>
+                <a:lumOff val="50000"/>
+              </a:schemeClr>
+            </a:solidFill>
+            <a:prstDash val="solid"/>
+            <a:round/>
+            <a:headEnd type="none" w="med" len="med"/>
+            <a:tailEnd type="none" w="med" len="med"/>
+          </a:ln>
+          <a:effectLst/>
+        </p:spPr>
+        <p:txBody>
+          <a:bodyPr vert="horz" wrap="square" lIns="63362" tIns="31681" rIns="63362" bIns="31681" numCol="1" rtlCol="0" anchor="t" anchorCtr="0" compatLnSpc="1">
+            <a:prstTxWarp prst="textNoShape">
+              <a:avLst/>
+            </a:prstTxWarp>
+          </a:bodyPr>
+          <a:lstStyle/>
+          <a:p>
+            <a:pPr defTabSz="633588"/>
+            <a:endParaRPr lang="en-US" sz="1663"/>
+          </a:p>
+        </p:txBody>
+      </p:sp>
+      <p:sp>
+        <p:nvSpPr>
+          <p:cNvPr id="26649" name="AI Disclosure Header"/>
+          <p:cNvSpPr txBox="1"/>
+          <p:nvPr/>
+        </p:nvSpPr>
+        <p:spPr>
+          <a:xfrm>
+            <a:off x="26147668" y="17964907"/>
+            <a:ext cx="3249734" cy="389635"/>
+          </a:xfrm>
+          <a:prstGeom prst="rect">
+            <a:avLst/>
+          </a:prstGeom>
+          <a:noFill/>
+        </p:spPr>
+        <p:txBody>
+          <a:bodyPr wrap="square">
+            <a:spAutoFit/>
+          </a:bodyPr>
+          <a:lstStyle/>
+          <a:p>
+            <a:pPr algn="ctr"/>
+            <a:r>
+              <a:rPr lang="en-US" sz="1941" b="1" dirty="0">
+                <a:solidFill>
+                  <a:srgbClr val="CFB991"/>
+                </a:solidFill>
+                <a:latin typeface="Arial" panose="020B0604020202020204" pitchFamily="34" charset="0"/>
+                <a:cs typeface="Arial" panose="020B0604020202020204" pitchFamily="34" charset="0"/>
+              </a:rPr>
+              <a:t>AI USE DISCLOSURE</a:t>
+            </a:r>
+          </a:p>
+        </p:txBody>
+      </p:sp>
+      <p:sp>
+        <p:nvSpPr>
+          <p:cNvPr id="26650" name="AI Disclosure Text"/>
+          <p:cNvSpPr txBox="1"/>
+          <p:nvPr/>
+        </p:nvSpPr>
+        <p:spPr>
+          <a:xfrm>
+            <a:off x="24484290" y="18609763"/>
+            <a:ext cx="5041304" cy="1735637"/>
+          </a:xfrm>
+          <a:prstGeom prst="rect">
+            <a:avLst/>
+          </a:prstGeom>
+          <a:noFill/>
+        </p:spPr>
+        <p:txBody>
+          <a:bodyPr wrap="square">
+            <a:spAutoFit/>
+          </a:bodyPr>
+          <a:lstStyle/>
+          <a:p>
+            <a:r>
+              <a:rPr lang="en-US" sz="1586" i="1" dirty="0"/>
+              <a:t>We used [AI tool and version, e.g., Gemini in Colab] to [task, e.g., debug code and edit text]. We reviewed and verified every AI-assisted output and take full responsibility for this poster. (If you used no AI tools, write: "No AI tools were used.")</a:t>
             </a:r>
             <a:endParaRPr lang="en-US" sz="1586" dirty="0"/>
           </a:p>

</xml_diff>

<commit_message>
fix: Align the poster rubric and template with the published notebooks
Until the Nov 8 notebook update, criterion 6 scores notebook 08's
three-outcome paired rule against a practical margin and the champion
selection notebook 14 teaches; the corrected interval, four outcomes
and delta move out of the rubric. Criterion 5 again asks for the CV mean
with its descriptive 95% interval. The template's methodology, results
and business-implication prompts follow nb08/nb14/nb17, and the
acknowledgements box now carries a references placeholder.

Co-Authored-By: Claude Opus 5.5 <noreply@anthropic.com>
</commit_message>
<xml_diff>
--- a/_final_project/2026F/template/qm474_poster_template.pptx
+++ b/_final_project/2026F/template/qm474_poster_template.pptx
@@ -10691,7 +10691,7 @@
                 <a:latin typeface="Arial" panose="020B0604020202020204" pitchFamily="34" charset="0"/>
                 <a:cs typeface="Arial" panose="020B0604020202020204" pitchFamily="34" charset="0"/>
               </a:rPr>
-              <a:t>• Methods used are appropriate and clear </a:t>
+              <a:t>• Leakage-safe pipeline; k-fold CV on the training data only </a:t>
             </a:r>
           </a:p>
           <a:p>
@@ -10701,7 +10701,7 @@
                 <a:latin typeface="Arial" panose="020B0604020202020204" pitchFamily="34" charset="0"/>
                 <a:cs typeface="Arial" panose="020B0604020202020204" pitchFamily="34" charset="0"/>
               </a:rPr>
-              <a:t>• Software and technologies used are clear </a:t>
+              <a:t>• Baseline first, then more complex models tuned inside CV </a:t>
             </a:r>
           </a:p>
           <a:p>
@@ -10711,7 +10711,7 @@
                 <a:latin typeface="Arial" panose="020B0604020202020204" pitchFamily="34" charset="0"/>
                 <a:cs typeface="Arial" panose="020B0604020202020204" pitchFamily="34" charset="0"/>
               </a:rPr>
-              <a:t>• Experiments performed support problem and answer questions</a:t>
+              <a:t>• Test set locked until the champion is chosen; software named</a:t>
             </a:r>
           </a:p>
         </p:txBody>
@@ -10819,7 +10819,7 @@
                 <a:latin typeface="Arial" panose="020B0604020202020204" pitchFamily="34" charset="0"/>
                 <a:cs typeface="Arial" panose="020B0604020202020204" pitchFamily="34" charset="0"/>
               </a:rPr>
-              <a:t>• Business validation of model/solution demonstrated </a:t>
+              <a:t>• The champion and the decision it changes, in your stakeholder's terms </a:t>
             </a:r>
           </a:p>
           <a:p>
@@ -10888,7 +10888,7 @@
                 <a:latin typeface="Arial" panose="020B0604020202020204" pitchFamily="34" charset="0"/>
                 <a:cs typeface="Arial" panose="020B0604020202020204" pitchFamily="34" charset="0"/>
               </a:rPr>
-              <a:t>• Model results clear and appropriately evaluated </a:t>
+              <a:t>• Headline metric: CV mean with its approximate 95% interval (descriptive) </a:t>
             </a:r>
           </a:p>
           <a:p>
@@ -10898,7 +10898,7 @@
                 <a:latin typeface="Arial" panose="020B0604020202020204" pitchFamily="34" charset="0"/>
                 <a:cs typeface="Arial" panose="020B0604020202020204" pitchFamily="34" charset="0"/>
               </a:rPr>
-              <a:t>• Demonstrated how models will/are to be used </a:t>
+              <a:t>• Champion vs. baseline on the same folds: per-fold differences vs. your margin </a:t>
             </a:r>
           </a:p>
           <a:p>
@@ -10908,7 +10908,7 @@
                 <a:latin typeface="Arial" panose="020B0604020202020204" pitchFamily="34" charset="0"/>
                 <a:cs typeface="Arial" panose="020B0604020202020204" pitchFamily="34" charset="0"/>
               </a:rPr>
-              <a:t>• Final model/solution structures or interpretations discussed as necessary </a:t>
+              <a:t>• Verdict: real difference, no winner, or practically equivalent (simpler wins) </a:t>
             </a:r>
           </a:p>
           <a:p>
@@ -10918,7 +10918,7 @@
                 <a:latin typeface="Arial" panose="020B0604020202020204" pitchFamily="34" charset="0"/>
                 <a:cs typeface="Arial" panose="020B0604020202020204" pitchFamily="34" charset="0"/>
               </a:rPr>
-              <a:t>• Areas for improvement identified</a:t>
+              <a:t>• One diagnostic: confusion matrix, calibration plot, or error by segment</a:t>
             </a:r>
           </a:p>
         </p:txBody>
@@ -11803,8 +11803,8 @@
         </p:nvSpPr>
         <p:spPr>
           <a:xfrm>
-            <a:off x="26147668" y="15660619"/>
-            <a:ext cx="3249734" cy="389635"/>
+            <a:off x="24298634" y="15660619"/>
+            <a:ext cx="6773131" cy="389635"/>
           </a:xfrm>
           <a:prstGeom prst="rect">
             <a:avLst/>
@@ -11826,7 +11826,7 @@
                 <a:latin typeface="Arial" panose="020B0604020202020204" pitchFamily="34" charset="0"/>
                 <a:cs typeface="Arial" panose="020B0604020202020204" pitchFamily="34" charset="0"/>
               </a:rPr>
-              <a:t>ACKNOWLEDGEMENTS</a:t>
+              <a:t>ACKNOWLEDGEMENTS &amp; REFERENCES</a:t>
             </a:r>
           </a:p>
         </p:txBody>
@@ -11865,6 +11865,13 @@
             </a:r>
             <a:endParaRPr lang="en-US" sz="1586" dirty="0"/>
           </a:p>
+          <a:p>
+            <a:r>
+              <a:rPr lang="en-US" sz="1586" i="1" dirty="0"/>
+              <a:t>References: [data source and URL]; [sources behind your business problem]; [software, e.g., scikit-learn, pandas].</a:t>
+            </a:r>
+            <a:endParaRPr lang="en-US" sz="1586" dirty="0"/>
+          </a:p>
         </p:txBody>
       </p:sp>
       <p:sp>
@@ -11875,7 +11882,7 @@
         </p:nvSpPr>
         <p:spPr bwMode="auto">
           <a:xfrm>
-            <a:off x="24298634" y="17940528"/>
+            <a:off x="24298634" y="18397728"/>
             <a:ext cx="6773131" cy="474338"/>
           </a:xfrm>
           <a:prstGeom prst="rect">
@@ -11919,7 +11926,7 @@
         </p:nvSpPr>
         <p:spPr>
           <a:xfrm>
-            <a:off x="26147668" y="17964907"/>
+            <a:off x="26147668" y="18422107"/>
             <a:ext cx="3249734" cy="389635"/>
           </a:xfrm>
           <a:prstGeom prst="rect">
@@ -11955,8 +11962,8 @@
         </p:nvSpPr>
         <p:spPr>
           <a:xfrm>
-            <a:off x="24484290" y="18609763"/>
-            <a:ext cx="5041304" cy="1735637"/>
+            <a:off x="24484290" y="19066963"/>
+            <a:ext cx="5041304" cy="1305869"/>
           </a:xfrm>
           <a:prstGeom prst="rect">
             <a:avLst/>

</xml_diff>